<commit_message>
Refresh picture fill diagnostic fixture
</commit_message>
<xml_diff>
--- a/tests/Lokad.OoxPdf.Tests/Cases/pptx-ladder-12-picture-fill-diagnostic.pptx
+++ b/tests/Lokad.OoxPdf.Tests/Cases/pptx-ladder-12-picture-fill-diagnostic.pptx
@@ -129,7 +129,7 @@
           <p:cNvPr id="2" name="Title 1">
             <a:extLst>
               <a:ext uri="{FF2B5EF4-FFF2-40B4-BE49-F238E27FC236}">
-                <a16:creationId xmlns:a16="http://schemas.microsoft.com/office/drawing/2014/main" id="{D7602097-128E-89BE-5643-423560D69199}"/>
+                <a16:creationId xmlns:a16="http://schemas.microsoft.com/office/drawing/2014/main" id="{32D2C8A5-420B-3475-2048-F3362995B67D}"/>
               </a:ext>
             </a:extLst>
           </p:cNvPr>
@@ -166,7 +166,7 @@
           <p:cNvPr id="3" name="Subtitle 2">
             <a:extLst>
               <a:ext uri="{FF2B5EF4-FFF2-40B4-BE49-F238E27FC236}">
-                <a16:creationId xmlns:a16="http://schemas.microsoft.com/office/drawing/2014/main" id="{07E93130-B24E-06F7-2037-22601BB95E3D}"/>
+                <a16:creationId xmlns:a16="http://schemas.microsoft.com/office/drawing/2014/main" id="{1CF32682-B6AF-2D47-C23A-861A6480E6D4}"/>
               </a:ext>
             </a:extLst>
           </p:cNvPr>
@@ -236,7 +236,7 @@
           <p:cNvPr id="4" name="Date Placeholder 3">
             <a:extLst>
               <a:ext uri="{FF2B5EF4-FFF2-40B4-BE49-F238E27FC236}">
-                <a16:creationId xmlns:a16="http://schemas.microsoft.com/office/drawing/2014/main" id="{45349DBB-7C2C-B618-6C17-7A761570A5E6}"/>
+                <a16:creationId xmlns:a16="http://schemas.microsoft.com/office/drawing/2014/main" id="{639C5888-BD29-9E5A-12B5-80D4EA06FD36}"/>
               </a:ext>
             </a:extLst>
           </p:cNvPr>
@@ -252,9 +252,9 @@
           <a:bodyPr/>
           <a:lstStyle/>
           <a:p>
-            <a:fld id="{CFB8CEE7-E106-44F4-BA0D-7FD856044FA9}" type="datetimeFigureOut">
+            <a:fld id="{12F0EA5F-F5AC-4C74-89EF-6C6D6C884FA9}" type="datetimeFigureOut">
               <a:rPr lang="en-US" smtClean="0"/>
-              <a:t>5/15/2026</a:t>
+              <a:t>5/16/2026</a:t>
             </a:fld>
             <a:endParaRPr lang="en-US"/>
           </a:p>
@@ -265,7 +265,7 @@
           <p:cNvPr id="5" name="Footer Placeholder 4">
             <a:extLst>
               <a:ext uri="{FF2B5EF4-FFF2-40B4-BE49-F238E27FC236}">
-                <a16:creationId xmlns:a16="http://schemas.microsoft.com/office/drawing/2014/main" id="{BD2BD2EB-38BF-43D7-28CF-BCE76D1184F3}"/>
+                <a16:creationId xmlns:a16="http://schemas.microsoft.com/office/drawing/2014/main" id="{54ADFCA4-6B2C-76FE-DC8C-5CC3D2A30C0A}"/>
               </a:ext>
             </a:extLst>
           </p:cNvPr>
@@ -290,7 +290,7 @@
           <p:cNvPr id="6" name="Slide Number Placeholder 5">
             <a:extLst>
               <a:ext uri="{FF2B5EF4-FFF2-40B4-BE49-F238E27FC236}">
-                <a16:creationId xmlns:a16="http://schemas.microsoft.com/office/drawing/2014/main" id="{0F1EE099-7C86-0F02-F4D9-1291764987D2}"/>
+                <a16:creationId xmlns:a16="http://schemas.microsoft.com/office/drawing/2014/main" id="{27001C38-9C22-FB73-446A-2E8A68CEC3B8}"/>
               </a:ext>
             </a:extLst>
           </p:cNvPr>
@@ -306,7 +306,7 @@
           <a:bodyPr/>
           <a:lstStyle/>
           <a:p>
-            <a:fld id="{DC776238-45DA-4189-B6CA-1B3359F0C924}" type="slidenum">
+            <a:fld id="{E9450F60-D1CA-4FC9-9791-AF0BFD194C99}" type="slidenum">
               <a:rPr lang="en-US" smtClean="0"/>
               <a:t>‹#›</a:t>
             </a:fld>
@@ -317,7 +317,7 @@
     </p:spTree>
     <p:extLst>
       <p:ext uri="{BB962C8B-B14F-4D97-AF65-F5344CB8AC3E}">
-        <p14:creationId xmlns:p14="http://schemas.microsoft.com/office/powerpoint/2010/main" val="2701019832"/>
+        <p14:creationId xmlns:p14="http://schemas.microsoft.com/office/powerpoint/2010/main" val="2046477718"/>
       </p:ext>
     </p:extLst>
   </p:cSld>
@@ -349,7 +349,7 @@
           <p:cNvPr id="2" name="Title 1">
             <a:extLst>
               <a:ext uri="{FF2B5EF4-FFF2-40B4-BE49-F238E27FC236}">
-                <a16:creationId xmlns:a16="http://schemas.microsoft.com/office/drawing/2014/main" id="{16DB52F4-2AFE-20D6-2867-329C32D067A9}"/>
+                <a16:creationId xmlns:a16="http://schemas.microsoft.com/office/drawing/2014/main" id="{7D579986-3AE5-2116-1E9B-704C8F6C66DB}"/>
               </a:ext>
             </a:extLst>
           </p:cNvPr>
@@ -377,7 +377,7 @@
           <p:cNvPr id="3" name="Vertical Text Placeholder 2">
             <a:extLst>
               <a:ext uri="{FF2B5EF4-FFF2-40B4-BE49-F238E27FC236}">
-                <a16:creationId xmlns:a16="http://schemas.microsoft.com/office/drawing/2014/main" id="{24AC0C18-AC8F-153D-0E65-24DF5E969960}"/>
+                <a16:creationId xmlns:a16="http://schemas.microsoft.com/office/drawing/2014/main" id="{24AAF381-A4B5-9C93-DC80-CB86E4AFA48D}"/>
               </a:ext>
             </a:extLst>
           </p:cNvPr>
@@ -434,7 +434,7 @@
           <p:cNvPr id="4" name="Date Placeholder 3">
             <a:extLst>
               <a:ext uri="{FF2B5EF4-FFF2-40B4-BE49-F238E27FC236}">
-                <a16:creationId xmlns:a16="http://schemas.microsoft.com/office/drawing/2014/main" id="{8F7B0B2D-9E51-F248-DAF2-98B927790944}"/>
+                <a16:creationId xmlns:a16="http://schemas.microsoft.com/office/drawing/2014/main" id="{EBF1C4EF-4838-DC5D-96D4-97819550FC80}"/>
               </a:ext>
             </a:extLst>
           </p:cNvPr>
@@ -450,9 +450,9 @@
           <a:bodyPr/>
           <a:lstStyle/>
           <a:p>
-            <a:fld id="{CFB8CEE7-E106-44F4-BA0D-7FD856044FA9}" type="datetimeFigureOut">
+            <a:fld id="{12F0EA5F-F5AC-4C74-89EF-6C6D6C884FA9}" type="datetimeFigureOut">
               <a:rPr lang="en-US" smtClean="0"/>
-              <a:t>5/15/2026</a:t>
+              <a:t>5/16/2026</a:t>
             </a:fld>
             <a:endParaRPr lang="en-US"/>
           </a:p>
@@ -463,7 +463,7 @@
           <p:cNvPr id="5" name="Footer Placeholder 4">
             <a:extLst>
               <a:ext uri="{FF2B5EF4-FFF2-40B4-BE49-F238E27FC236}">
-                <a16:creationId xmlns:a16="http://schemas.microsoft.com/office/drawing/2014/main" id="{1B12A7C0-0A29-0546-1B23-B482C80B3119}"/>
+                <a16:creationId xmlns:a16="http://schemas.microsoft.com/office/drawing/2014/main" id="{DE78A03B-9BFB-D621-2EF7-4A7CE4C6244B}"/>
               </a:ext>
             </a:extLst>
           </p:cNvPr>
@@ -488,7 +488,7 @@
           <p:cNvPr id="6" name="Slide Number Placeholder 5">
             <a:extLst>
               <a:ext uri="{FF2B5EF4-FFF2-40B4-BE49-F238E27FC236}">
-                <a16:creationId xmlns:a16="http://schemas.microsoft.com/office/drawing/2014/main" id="{0324FC92-3931-9D24-A060-63EAF72986E6}"/>
+                <a16:creationId xmlns:a16="http://schemas.microsoft.com/office/drawing/2014/main" id="{6F3B33D3-7911-B7DD-6C98-1E1396AEC869}"/>
               </a:ext>
             </a:extLst>
           </p:cNvPr>
@@ -504,7 +504,7 @@
           <a:bodyPr/>
           <a:lstStyle/>
           <a:p>
-            <a:fld id="{DC776238-45DA-4189-B6CA-1B3359F0C924}" type="slidenum">
+            <a:fld id="{E9450F60-D1CA-4FC9-9791-AF0BFD194C99}" type="slidenum">
               <a:rPr lang="en-US" smtClean="0"/>
               <a:t>‹#›</a:t>
             </a:fld>
@@ -515,7 +515,7 @@
     </p:spTree>
     <p:extLst>
       <p:ext uri="{BB962C8B-B14F-4D97-AF65-F5344CB8AC3E}">
-        <p14:creationId xmlns:p14="http://schemas.microsoft.com/office/powerpoint/2010/main" val="995214407"/>
+        <p14:creationId xmlns:p14="http://schemas.microsoft.com/office/powerpoint/2010/main" val="3400489721"/>
       </p:ext>
     </p:extLst>
   </p:cSld>
@@ -547,7 +547,7 @@
           <p:cNvPr id="2" name="Vertical Title 1">
             <a:extLst>
               <a:ext uri="{FF2B5EF4-FFF2-40B4-BE49-F238E27FC236}">
-                <a16:creationId xmlns:a16="http://schemas.microsoft.com/office/drawing/2014/main" id="{330408C4-96A4-51C1-8A19-8DBFC257EBE1}"/>
+                <a16:creationId xmlns:a16="http://schemas.microsoft.com/office/drawing/2014/main" id="{90E71105-802C-78BB-FCCF-5DC206F84653}"/>
               </a:ext>
             </a:extLst>
           </p:cNvPr>
@@ -580,7 +580,7 @@
           <p:cNvPr id="3" name="Vertical Text Placeholder 2">
             <a:extLst>
               <a:ext uri="{FF2B5EF4-FFF2-40B4-BE49-F238E27FC236}">
-                <a16:creationId xmlns:a16="http://schemas.microsoft.com/office/drawing/2014/main" id="{BAEDF66F-62CD-682A-47EF-8CA7B00E6EF9}"/>
+                <a16:creationId xmlns:a16="http://schemas.microsoft.com/office/drawing/2014/main" id="{CD0EC886-35A9-45DA-CC02-23F45533854B}"/>
               </a:ext>
             </a:extLst>
           </p:cNvPr>
@@ -642,7 +642,7 @@
           <p:cNvPr id="4" name="Date Placeholder 3">
             <a:extLst>
               <a:ext uri="{FF2B5EF4-FFF2-40B4-BE49-F238E27FC236}">
-                <a16:creationId xmlns:a16="http://schemas.microsoft.com/office/drawing/2014/main" id="{ADD1FB60-FBA8-3EDC-5A6A-C43A6CC1BFCA}"/>
+                <a16:creationId xmlns:a16="http://schemas.microsoft.com/office/drawing/2014/main" id="{3D015CAF-195B-7117-1FB5-77BE5615F60B}"/>
               </a:ext>
             </a:extLst>
           </p:cNvPr>
@@ -658,9 +658,9 @@
           <a:bodyPr/>
           <a:lstStyle/>
           <a:p>
-            <a:fld id="{CFB8CEE7-E106-44F4-BA0D-7FD856044FA9}" type="datetimeFigureOut">
+            <a:fld id="{12F0EA5F-F5AC-4C74-89EF-6C6D6C884FA9}" type="datetimeFigureOut">
               <a:rPr lang="en-US" smtClean="0"/>
-              <a:t>5/15/2026</a:t>
+              <a:t>5/16/2026</a:t>
             </a:fld>
             <a:endParaRPr lang="en-US"/>
           </a:p>
@@ -671,7 +671,7 @@
           <p:cNvPr id="5" name="Footer Placeholder 4">
             <a:extLst>
               <a:ext uri="{FF2B5EF4-FFF2-40B4-BE49-F238E27FC236}">
-                <a16:creationId xmlns:a16="http://schemas.microsoft.com/office/drawing/2014/main" id="{5D9416E5-D447-AC30-0971-30873CE9BD85}"/>
+                <a16:creationId xmlns:a16="http://schemas.microsoft.com/office/drawing/2014/main" id="{6F6524EF-BF7D-672B-4DCE-DAB7151C3083}"/>
               </a:ext>
             </a:extLst>
           </p:cNvPr>
@@ -696,7 +696,7 @@
           <p:cNvPr id="6" name="Slide Number Placeholder 5">
             <a:extLst>
               <a:ext uri="{FF2B5EF4-FFF2-40B4-BE49-F238E27FC236}">
-                <a16:creationId xmlns:a16="http://schemas.microsoft.com/office/drawing/2014/main" id="{6E5318BE-F39F-598B-53CE-E2F56C4DA646}"/>
+                <a16:creationId xmlns:a16="http://schemas.microsoft.com/office/drawing/2014/main" id="{2FD7C308-3896-AB22-D9E1-670FEE96663E}"/>
               </a:ext>
             </a:extLst>
           </p:cNvPr>
@@ -712,7 +712,7 @@
           <a:bodyPr/>
           <a:lstStyle/>
           <a:p>
-            <a:fld id="{DC776238-45DA-4189-B6CA-1B3359F0C924}" type="slidenum">
+            <a:fld id="{E9450F60-D1CA-4FC9-9791-AF0BFD194C99}" type="slidenum">
               <a:rPr lang="en-US" smtClean="0"/>
               <a:t>‹#›</a:t>
             </a:fld>
@@ -723,7 +723,7 @@
     </p:spTree>
     <p:extLst>
       <p:ext uri="{BB962C8B-B14F-4D97-AF65-F5344CB8AC3E}">
-        <p14:creationId xmlns:p14="http://schemas.microsoft.com/office/powerpoint/2010/main" val="1327022073"/>
+        <p14:creationId xmlns:p14="http://schemas.microsoft.com/office/powerpoint/2010/main" val="1512000405"/>
       </p:ext>
     </p:extLst>
   </p:cSld>
@@ -755,7 +755,7 @@
           <p:cNvPr id="2" name="Title 1">
             <a:extLst>
               <a:ext uri="{FF2B5EF4-FFF2-40B4-BE49-F238E27FC236}">
-                <a16:creationId xmlns:a16="http://schemas.microsoft.com/office/drawing/2014/main" id="{6721813D-54B4-CFB7-9A6F-16AFB610821E}"/>
+                <a16:creationId xmlns:a16="http://schemas.microsoft.com/office/drawing/2014/main" id="{11742182-79A3-8B84-A3F9-C83A3F22E89B}"/>
               </a:ext>
             </a:extLst>
           </p:cNvPr>
@@ -783,7 +783,7 @@
           <p:cNvPr id="3" name="Content Placeholder 2">
             <a:extLst>
               <a:ext uri="{FF2B5EF4-FFF2-40B4-BE49-F238E27FC236}">
-                <a16:creationId xmlns:a16="http://schemas.microsoft.com/office/drawing/2014/main" id="{EAF22407-D61F-B650-A4B1-E8CEF12D378F}"/>
+                <a16:creationId xmlns:a16="http://schemas.microsoft.com/office/drawing/2014/main" id="{ADC52AF3-2639-847B-AA22-A9EA42E7CEE9}"/>
               </a:ext>
             </a:extLst>
           </p:cNvPr>
@@ -840,7 +840,7 @@
           <p:cNvPr id="4" name="Date Placeholder 3">
             <a:extLst>
               <a:ext uri="{FF2B5EF4-FFF2-40B4-BE49-F238E27FC236}">
-                <a16:creationId xmlns:a16="http://schemas.microsoft.com/office/drawing/2014/main" id="{70682B8B-007D-A0D7-17FA-8B39B3BCB59E}"/>
+                <a16:creationId xmlns:a16="http://schemas.microsoft.com/office/drawing/2014/main" id="{273E1961-AFB6-1AF8-CD52-9EE19B53EFAC}"/>
               </a:ext>
             </a:extLst>
           </p:cNvPr>
@@ -856,9 +856,9 @@
           <a:bodyPr/>
           <a:lstStyle/>
           <a:p>
-            <a:fld id="{CFB8CEE7-E106-44F4-BA0D-7FD856044FA9}" type="datetimeFigureOut">
+            <a:fld id="{12F0EA5F-F5AC-4C74-89EF-6C6D6C884FA9}" type="datetimeFigureOut">
               <a:rPr lang="en-US" smtClean="0"/>
-              <a:t>5/15/2026</a:t>
+              <a:t>5/16/2026</a:t>
             </a:fld>
             <a:endParaRPr lang="en-US"/>
           </a:p>
@@ -869,7 +869,7 @@
           <p:cNvPr id="5" name="Footer Placeholder 4">
             <a:extLst>
               <a:ext uri="{FF2B5EF4-FFF2-40B4-BE49-F238E27FC236}">
-                <a16:creationId xmlns:a16="http://schemas.microsoft.com/office/drawing/2014/main" id="{D29FF7E7-7E83-D494-AB49-48310C3870D0}"/>
+                <a16:creationId xmlns:a16="http://schemas.microsoft.com/office/drawing/2014/main" id="{DB9D544D-5E10-1AE1-3CF7-EBB673A96A1B}"/>
               </a:ext>
             </a:extLst>
           </p:cNvPr>
@@ -894,7 +894,7 @@
           <p:cNvPr id="6" name="Slide Number Placeholder 5">
             <a:extLst>
               <a:ext uri="{FF2B5EF4-FFF2-40B4-BE49-F238E27FC236}">
-                <a16:creationId xmlns:a16="http://schemas.microsoft.com/office/drawing/2014/main" id="{335C34ED-17DF-0A32-CF49-7FC29E3E47F8}"/>
+                <a16:creationId xmlns:a16="http://schemas.microsoft.com/office/drawing/2014/main" id="{DEC065AB-4146-DC1E-F9ED-FABA8C33B582}"/>
               </a:ext>
             </a:extLst>
           </p:cNvPr>
@@ -910,7 +910,7 @@
           <a:bodyPr/>
           <a:lstStyle/>
           <a:p>
-            <a:fld id="{DC776238-45DA-4189-B6CA-1B3359F0C924}" type="slidenum">
+            <a:fld id="{E9450F60-D1CA-4FC9-9791-AF0BFD194C99}" type="slidenum">
               <a:rPr lang="en-US" smtClean="0"/>
               <a:t>‹#›</a:t>
             </a:fld>
@@ -921,7 +921,7 @@
     </p:spTree>
     <p:extLst>
       <p:ext uri="{BB962C8B-B14F-4D97-AF65-F5344CB8AC3E}">
-        <p14:creationId xmlns:p14="http://schemas.microsoft.com/office/powerpoint/2010/main" val="3313887542"/>
+        <p14:creationId xmlns:p14="http://schemas.microsoft.com/office/powerpoint/2010/main" val="2634232255"/>
       </p:ext>
     </p:extLst>
   </p:cSld>
@@ -953,7 +953,7 @@
           <p:cNvPr id="2" name="Title 1">
             <a:extLst>
               <a:ext uri="{FF2B5EF4-FFF2-40B4-BE49-F238E27FC236}">
-                <a16:creationId xmlns:a16="http://schemas.microsoft.com/office/drawing/2014/main" id="{83A6E7BB-1D5B-9044-5967-252697C4DCF1}"/>
+                <a16:creationId xmlns:a16="http://schemas.microsoft.com/office/drawing/2014/main" id="{C21C3FD1-CD54-AB46-2C00-E2C1D30908B8}"/>
               </a:ext>
             </a:extLst>
           </p:cNvPr>
@@ -990,7 +990,7 @@
           <p:cNvPr id="3" name="Text Placeholder 2">
             <a:extLst>
               <a:ext uri="{FF2B5EF4-FFF2-40B4-BE49-F238E27FC236}">
-                <a16:creationId xmlns:a16="http://schemas.microsoft.com/office/drawing/2014/main" id="{802E6C41-36FC-9423-CE3C-585E9FE24999}"/>
+                <a16:creationId xmlns:a16="http://schemas.microsoft.com/office/drawing/2014/main" id="{26E1082C-E474-6F3C-D0B0-5848D7411A51}"/>
               </a:ext>
             </a:extLst>
           </p:cNvPr>
@@ -1115,7 +1115,7 @@
           <p:cNvPr id="4" name="Date Placeholder 3">
             <a:extLst>
               <a:ext uri="{FF2B5EF4-FFF2-40B4-BE49-F238E27FC236}">
-                <a16:creationId xmlns:a16="http://schemas.microsoft.com/office/drawing/2014/main" id="{1A96C1DB-7CE8-81FE-EB4F-C40AC38EC71F}"/>
+                <a16:creationId xmlns:a16="http://schemas.microsoft.com/office/drawing/2014/main" id="{97A9D529-963A-FFCC-30D7-2387269FF4FE}"/>
               </a:ext>
             </a:extLst>
           </p:cNvPr>
@@ -1131,9 +1131,9 @@
           <a:bodyPr/>
           <a:lstStyle/>
           <a:p>
-            <a:fld id="{CFB8CEE7-E106-44F4-BA0D-7FD856044FA9}" type="datetimeFigureOut">
+            <a:fld id="{12F0EA5F-F5AC-4C74-89EF-6C6D6C884FA9}" type="datetimeFigureOut">
               <a:rPr lang="en-US" smtClean="0"/>
-              <a:t>5/15/2026</a:t>
+              <a:t>5/16/2026</a:t>
             </a:fld>
             <a:endParaRPr lang="en-US"/>
           </a:p>
@@ -1144,7 +1144,7 @@
           <p:cNvPr id="5" name="Footer Placeholder 4">
             <a:extLst>
               <a:ext uri="{FF2B5EF4-FFF2-40B4-BE49-F238E27FC236}">
-                <a16:creationId xmlns:a16="http://schemas.microsoft.com/office/drawing/2014/main" id="{BC7D5EEB-5922-CCA7-8A1A-3F7AAC05582E}"/>
+                <a16:creationId xmlns:a16="http://schemas.microsoft.com/office/drawing/2014/main" id="{835E91A5-21E8-4BFE-A30A-B1D60849A1D1}"/>
               </a:ext>
             </a:extLst>
           </p:cNvPr>
@@ -1169,7 +1169,7 @@
           <p:cNvPr id="6" name="Slide Number Placeholder 5">
             <a:extLst>
               <a:ext uri="{FF2B5EF4-FFF2-40B4-BE49-F238E27FC236}">
-                <a16:creationId xmlns:a16="http://schemas.microsoft.com/office/drawing/2014/main" id="{5E5DC4DF-02C6-B402-5E65-A9AC7911B301}"/>
+                <a16:creationId xmlns:a16="http://schemas.microsoft.com/office/drawing/2014/main" id="{EA2D6D08-7A13-E164-23DD-31B3A350789F}"/>
               </a:ext>
             </a:extLst>
           </p:cNvPr>
@@ -1185,7 +1185,7 @@
           <a:bodyPr/>
           <a:lstStyle/>
           <a:p>
-            <a:fld id="{DC776238-45DA-4189-B6CA-1B3359F0C924}" type="slidenum">
+            <a:fld id="{E9450F60-D1CA-4FC9-9791-AF0BFD194C99}" type="slidenum">
               <a:rPr lang="en-US" smtClean="0"/>
               <a:t>‹#›</a:t>
             </a:fld>
@@ -1196,7 +1196,7 @@
     </p:spTree>
     <p:extLst>
       <p:ext uri="{BB962C8B-B14F-4D97-AF65-F5344CB8AC3E}">
-        <p14:creationId xmlns:p14="http://schemas.microsoft.com/office/powerpoint/2010/main" val="1891471220"/>
+        <p14:creationId xmlns:p14="http://schemas.microsoft.com/office/powerpoint/2010/main" val="1829204663"/>
       </p:ext>
     </p:extLst>
   </p:cSld>
@@ -1228,7 +1228,7 @@
           <p:cNvPr id="2" name="Title 1">
             <a:extLst>
               <a:ext uri="{FF2B5EF4-FFF2-40B4-BE49-F238E27FC236}">
-                <a16:creationId xmlns:a16="http://schemas.microsoft.com/office/drawing/2014/main" id="{232D30FA-038A-A4C0-4A33-D2C02D738108}"/>
+                <a16:creationId xmlns:a16="http://schemas.microsoft.com/office/drawing/2014/main" id="{53BE1E4E-F8B7-1F70-1DF0-3B80E0266DDB}"/>
               </a:ext>
             </a:extLst>
           </p:cNvPr>
@@ -1256,7 +1256,7 @@
           <p:cNvPr id="3" name="Content Placeholder 2">
             <a:extLst>
               <a:ext uri="{FF2B5EF4-FFF2-40B4-BE49-F238E27FC236}">
-                <a16:creationId xmlns:a16="http://schemas.microsoft.com/office/drawing/2014/main" id="{D83A5380-45D9-2F4C-711A-C645E3E02159}"/>
+                <a16:creationId xmlns:a16="http://schemas.microsoft.com/office/drawing/2014/main" id="{CE1FDBBB-1E30-3E5D-CD29-19D7F2BD8ABE}"/>
               </a:ext>
             </a:extLst>
           </p:cNvPr>
@@ -1318,7 +1318,7 @@
           <p:cNvPr id="4" name="Content Placeholder 3">
             <a:extLst>
               <a:ext uri="{FF2B5EF4-FFF2-40B4-BE49-F238E27FC236}">
-                <a16:creationId xmlns:a16="http://schemas.microsoft.com/office/drawing/2014/main" id="{5AF21AD7-B57F-4292-34AB-3C7CAD3916C9}"/>
+                <a16:creationId xmlns:a16="http://schemas.microsoft.com/office/drawing/2014/main" id="{EA971E0C-00EC-8730-871F-D7E682C47953}"/>
               </a:ext>
             </a:extLst>
           </p:cNvPr>
@@ -1380,7 +1380,7 @@
           <p:cNvPr id="5" name="Date Placeholder 4">
             <a:extLst>
               <a:ext uri="{FF2B5EF4-FFF2-40B4-BE49-F238E27FC236}">
-                <a16:creationId xmlns:a16="http://schemas.microsoft.com/office/drawing/2014/main" id="{8B2A1FAB-E3B3-E594-8EED-B5C5EF311E88}"/>
+                <a16:creationId xmlns:a16="http://schemas.microsoft.com/office/drawing/2014/main" id="{1C1B1833-08DA-355E-4EF1-3A5E1EF4391B}"/>
               </a:ext>
             </a:extLst>
           </p:cNvPr>
@@ -1396,9 +1396,9 @@
           <a:bodyPr/>
           <a:lstStyle/>
           <a:p>
-            <a:fld id="{CFB8CEE7-E106-44F4-BA0D-7FD856044FA9}" type="datetimeFigureOut">
+            <a:fld id="{12F0EA5F-F5AC-4C74-89EF-6C6D6C884FA9}" type="datetimeFigureOut">
               <a:rPr lang="en-US" smtClean="0"/>
-              <a:t>5/15/2026</a:t>
+              <a:t>5/16/2026</a:t>
             </a:fld>
             <a:endParaRPr lang="en-US"/>
           </a:p>
@@ -1409,7 +1409,7 @@
           <p:cNvPr id="6" name="Footer Placeholder 5">
             <a:extLst>
               <a:ext uri="{FF2B5EF4-FFF2-40B4-BE49-F238E27FC236}">
-                <a16:creationId xmlns:a16="http://schemas.microsoft.com/office/drawing/2014/main" id="{61A32C84-B749-EE06-A59B-B559481AB3E3}"/>
+                <a16:creationId xmlns:a16="http://schemas.microsoft.com/office/drawing/2014/main" id="{BF867597-D833-23C2-FA7A-7BD8C714B52B}"/>
               </a:ext>
             </a:extLst>
           </p:cNvPr>
@@ -1434,7 +1434,7 @@
           <p:cNvPr id="7" name="Slide Number Placeholder 6">
             <a:extLst>
               <a:ext uri="{FF2B5EF4-FFF2-40B4-BE49-F238E27FC236}">
-                <a16:creationId xmlns:a16="http://schemas.microsoft.com/office/drawing/2014/main" id="{4C4C6640-9E81-6043-96FC-6FAFED0019E4}"/>
+                <a16:creationId xmlns:a16="http://schemas.microsoft.com/office/drawing/2014/main" id="{4A591E5C-D96A-E3DD-C332-1E2D72C90126}"/>
               </a:ext>
             </a:extLst>
           </p:cNvPr>
@@ -1450,7 +1450,7 @@
           <a:bodyPr/>
           <a:lstStyle/>
           <a:p>
-            <a:fld id="{DC776238-45DA-4189-B6CA-1B3359F0C924}" type="slidenum">
+            <a:fld id="{E9450F60-D1CA-4FC9-9791-AF0BFD194C99}" type="slidenum">
               <a:rPr lang="en-US" smtClean="0"/>
               <a:t>‹#›</a:t>
             </a:fld>
@@ -1461,7 +1461,7 @@
     </p:spTree>
     <p:extLst>
       <p:ext uri="{BB962C8B-B14F-4D97-AF65-F5344CB8AC3E}">
-        <p14:creationId xmlns:p14="http://schemas.microsoft.com/office/powerpoint/2010/main" val="3815680136"/>
+        <p14:creationId xmlns:p14="http://schemas.microsoft.com/office/powerpoint/2010/main" val="3721122080"/>
       </p:ext>
     </p:extLst>
   </p:cSld>
@@ -1493,7 +1493,7 @@
           <p:cNvPr id="2" name="Title 1">
             <a:extLst>
               <a:ext uri="{FF2B5EF4-FFF2-40B4-BE49-F238E27FC236}">
-                <a16:creationId xmlns:a16="http://schemas.microsoft.com/office/drawing/2014/main" id="{55919D61-E29E-9AB5-D639-F211F9D6A264}"/>
+                <a16:creationId xmlns:a16="http://schemas.microsoft.com/office/drawing/2014/main" id="{C4D16D48-A7EF-7E8B-2C26-BE842AC1F7C4}"/>
               </a:ext>
             </a:extLst>
           </p:cNvPr>
@@ -1526,7 +1526,7 @@
           <p:cNvPr id="3" name="Text Placeholder 2">
             <a:extLst>
               <a:ext uri="{FF2B5EF4-FFF2-40B4-BE49-F238E27FC236}">
-                <a16:creationId xmlns:a16="http://schemas.microsoft.com/office/drawing/2014/main" id="{654BA23B-63F8-42CC-B0F2-728DE1820A48}"/>
+                <a16:creationId xmlns:a16="http://schemas.microsoft.com/office/drawing/2014/main" id="{2F6D9FA5-7113-2157-91DE-9435D99B4D4A}"/>
               </a:ext>
             </a:extLst>
           </p:cNvPr>
@@ -1597,7 +1597,7 @@
           <p:cNvPr id="4" name="Content Placeholder 3">
             <a:extLst>
               <a:ext uri="{FF2B5EF4-FFF2-40B4-BE49-F238E27FC236}">
-                <a16:creationId xmlns:a16="http://schemas.microsoft.com/office/drawing/2014/main" id="{E0248452-9553-CF2E-8814-4A594F3F0B98}"/>
+                <a16:creationId xmlns:a16="http://schemas.microsoft.com/office/drawing/2014/main" id="{177B6AE5-63F0-7067-D455-6B51621604E8}"/>
               </a:ext>
             </a:extLst>
           </p:cNvPr>
@@ -1659,7 +1659,7 @@
           <p:cNvPr id="5" name="Text Placeholder 4">
             <a:extLst>
               <a:ext uri="{FF2B5EF4-FFF2-40B4-BE49-F238E27FC236}">
-                <a16:creationId xmlns:a16="http://schemas.microsoft.com/office/drawing/2014/main" id="{502CC16E-9301-77B1-D2CB-7189F1E12EEA}"/>
+                <a16:creationId xmlns:a16="http://schemas.microsoft.com/office/drawing/2014/main" id="{9A23F294-EE11-25CC-0CE5-63E8E850959D}"/>
               </a:ext>
             </a:extLst>
           </p:cNvPr>
@@ -1730,7 +1730,7 @@
           <p:cNvPr id="6" name="Content Placeholder 5">
             <a:extLst>
               <a:ext uri="{FF2B5EF4-FFF2-40B4-BE49-F238E27FC236}">
-                <a16:creationId xmlns:a16="http://schemas.microsoft.com/office/drawing/2014/main" id="{BDDFC94D-4513-0DCA-32A4-DFB3D52B81D8}"/>
+                <a16:creationId xmlns:a16="http://schemas.microsoft.com/office/drawing/2014/main" id="{EB7B01B0-1058-A787-1C44-0115767DA527}"/>
               </a:ext>
             </a:extLst>
           </p:cNvPr>
@@ -1792,7 +1792,7 @@
           <p:cNvPr id="7" name="Date Placeholder 6">
             <a:extLst>
               <a:ext uri="{FF2B5EF4-FFF2-40B4-BE49-F238E27FC236}">
-                <a16:creationId xmlns:a16="http://schemas.microsoft.com/office/drawing/2014/main" id="{F92E730E-7698-D99E-F104-4D701F24E871}"/>
+                <a16:creationId xmlns:a16="http://schemas.microsoft.com/office/drawing/2014/main" id="{B5C78F46-08C0-8750-1F31-A96730C30574}"/>
               </a:ext>
             </a:extLst>
           </p:cNvPr>
@@ -1808,9 +1808,9 @@
           <a:bodyPr/>
           <a:lstStyle/>
           <a:p>
-            <a:fld id="{CFB8CEE7-E106-44F4-BA0D-7FD856044FA9}" type="datetimeFigureOut">
+            <a:fld id="{12F0EA5F-F5AC-4C74-89EF-6C6D6C884FA9}" type="datetimeFigureOut">
               <a:rPr lang="en-US" smtClean="0"/>
-              <a:t>5/15/2026</a:t>
+              <a:t>5/16/2026</a:t>
             </a:fld>
             <a:endParaRPr lang="en-US"/>
           </a:p>
@@ -1821,7 +1821,7 @@
           <p:cNvPr id="8" name="Footer Placeholder 7">
             <a:extLst>
               <a:ext uri="{FF2B5EF4-FFF2-40B4-BE49-F238E27FC236}">
-                <a16:creationId xmlns:a16="http://schemas.microsoft.com/office/drawing/2014/main" id="{384E7A74-7554-6166-5515-87107A5DFA14}"/>
+                <a16:creationId xmlns:a16="http://schemas.microsoft.com/office/drawing/2014/main" id="{5CFECD3C-1495-3C40-6D53-8308A42E9165}"/>
               </a:ext>
             </a:extLst>
           </p:cNvPr>
@@ -1846,7 +1846,7 @@
           <p:cNvPr id="9" name="Slide Number Placeholder 8">
             <a:extLst>
               <a:ext uri="{FF2B5EF4-FFF2-40B4-BE49-F238E27FC236}">
-                <a16:creationId xmlns:a16="http://schemas.microsoft.com/office/drawing/2014/main" id="{8AA2B8F3-5A1B-6C05-B3AA-8E48413A8ED7}"/>
+                <a16:creationId xmlns:a16="http://schemas.microsoft.com/office/drawing/2014/main" id="{7E70AF7F-FA32-39D5-5727-002B71C2E8F8}"/>
               </a:ext>
             </a:extLst>
           </p:cNvPr>
@@ -1862,7 +1862,7 @@
           <a:bodyPr/>
           <a:lstStyle/>
           <a:p>
-            <a:fld id="{DC776238-45DA-4189-B6CA-1B3359F0C924}" type="slidenum">
+            <a:fld id="{E9450F60-D1CA-4FC9-9791-AF0BFD194C99}" type="slidenum">
               <a:rPr lang="en-US" smtClean="0"/>
               <a:t>‹#›</a:t>
             </a:fld>
@@ -1873,7 +1873,7 @@
     </p:spTree>
     <p:extLst>
       <p:ext uri="{BB962C8B-B14F-4D97-AF65-F5344CB8AC3E}">
-        <p14:creationId xmlns:p14="http://schemas.microsoft.com/office/powerpoint/2010/main" val="3555234549"/>
+        <p14:creationId xmlns:p14="http://schemas.microsoft.com/office/powerpoint/2010/main" val="1234737889"/>
       </p:ext>
     </p:extLst>
   </p:cSld>
@@ -1905,7 +1905,7 @@
           <p:cNvPr id="2" name="Title 1">
             <a:extLst>
               <a:ext uri="{FF2B5EF4-FFF2-40B4-BE49-F238E27FC236}">
-                <a16:creationId xmlns:a16="http://schemas.microsoft.com/office/drawing/2014/main" id="{115C364B-7FEA-882E-A5E0-871896FF871B}"/>
+                <a16:creationId xmlns:a16="http://schemas.microsoft.com/office/drawing/2014/main" id="{D0FF7BB0-B63A-865C-A43E-0B1FB5357B73}"/>
               </a:ext>
             </a:extLst>
           </p:cNvPr>
@@ -1933,7 +1933,7 @@
           <p:cNvPr id="3" name="Date Placeholder 2">
             <a:extLst>
               <a:ext uri="{FF2B5EF4-FFF2-40B4-BE49-F238E27FC236}">
-                <a16:creationId xmlns:a16="http://schemas.microsoft.com/office/drawing/2014/main" id="{1B22EDCA-8749-27C4-7CCB-D8E3E25E7DDF}"/>
+                <a16:creationId xmlns:a16="http://schemas.microsoft.com/office/drawing/2014/main" id="{C7E4B409-44C2-8343-3212-55A617C35BAF}"/>
               </a:ext>
             </a:extLst>
           </p:cNvPr>
@@ -1949,9 +1949,9 @@
           <a:bodyPr/>
           <a:lstStyle/>
           <a:p>
-            <a:fld id="{CFB8CEE7-E106-44F4-BA0D-7FD856044FA9}" type="datetimeFigureOut">
+            <a:fld id="{12F0EA5F-F5AC-4C74-89EF-6C6D6C884FA9}" type="datetimeFigureOut">
               <a:rPr lang="en-US" smtClean="0"/>
-              <a:t>5/15/2026</a:t>
+              <a:t>5/16/2026</a:t>
             </a:fld>
             <a:endParaRPr lang="en-US"/>
           </a:p>
@@ -1962,7 +1962,7 @@
           <p:cNvPr id="4" name="Footer Placeholder 3">
             <a:extLst>
               <a:ext uri="{FF2B5EF4-FFF2-40B4-BE49-F238E27FC236}">
-                <a16:creationId xmlns:a16="http://schemas.microsoft.com/office/drawing/2014/main" id="{62439361-805A-043A-CBAD-1AE30E210686}"/>
+                <a16:creationId xmlns:a16="http://schemas.microsoft.com/office/drawing/2014/main" id="{7EF65DEC-241A-44CE-2092-47501BB96573}"/>
               </a:ext>
             </a:extLst>
           </p:cNvPr>
@@ -1987,7 +1987,7 @@
           <p:cNvPr id="5" name="Slide Number Placeholder 4">
             <a:extLst>
               <a:ext uri="{FF2B5EF4-FFF2-40B4-BE49-F238E27FC236}">
-                <a16:creationId xmlns:a16="http://schemas.microsoft.com/office/drawing/2014/main" id="{2E2CF0CB-E6DC-FCC3-0A18-2349D160CB2E}"/>
+                <a16:creationId xmlns:a16="http://schemas.microsoft.com/office/drawing/2014/main" id="{BE6125BF-BDE7-1120-21EC-6175BBA122A4}"/>
               </a:ext>
             </a:extLst>
           </p:cNvPr>
@@ -2003,7 +2003,7 @@
           <a:bodyPr/>
           <a:lstStyle/>
           <a:p>
-            <a:fld id="{DC776238-45DA-4189-B6CA-1B3359F0C924}" type="slidenum">
+            <a:fld id="{E9450F60-D1CA-4FC9-9791-AF0BFD194C99}" type="slidenum">
               <a:rPr lang="en-US" smtClean="0"/>
               <a:t>‹#›</a:t>
             </a:fld>
@@ -2014,7 +2014,7 @@
     </p:spTree>
     <p:extLst>
       <p:ext uri="{BB962C8B-B14F-4D97-AF65-F5344CB8AC3E}">
-        <p14:creationId xmlns:p14="http://schemas.microsoft.com/office/powerpoint/2010/main" val="2585677855"/>
+        <p14:creationId xmlns:p14="http://schemas.microsoft.com/office/powerpoint/2010/main" val="1643868552"/>
       </p:ext>
     </p:extLst>
   </p:cSld>
@@ -2046,7 +2046,7 @@
           <p:cNvPr id="2" name="Date Placeholder 1">
             <a:extLst>
               <a:ext uri="{FF2B5EF4-FFF2-40B4-BE49-F238E27FC236}">
-                <a16:creationId xmlns:a16="http://schemas.microsoft.com/office/drawing/2014/main" id="{772FAE79-F5A2-9F42-54BC-B9B9B0A9AE8E}"/>
+                <a16:creationId xmlns:a16="http://schemas.microsoft.com/office/drawing/2014/main" id="{38F3FA14-A18F-21DA-2DB7-FBE27ECA0048}"/>
               </a:ext>
             </a:extLst>
           </p:cNvPr>
@@ -2062,9 +2062,9 @@
           <a:bodyPr/>
           <a:lstStyle/>
           <a:p>
-            <a:fld id="{CFB8CEE7-E106-44F4-BA0D-7FD856044FA9}" type="datetimeFigureOut">
+            <a:fld id="{12F0EA5F-F5AC-4C74-89EF-6C6D6C884FA9}" type="datetimeFigureOut">
               <a:rPr lang="en-US" smtClean="0"/>
-              <a:t>5/15/2026</a:t>
+              <a:t>5/16/2026</a:t>
             </a:fld>
             <a:endParaRPr lang="en-US"/>
           </a:p>
@@ -2075,7 +2075,7 @@
           <p:cNvPr id="3" name="Footer Placeholder 2">
             <a:extLst>
               <a:ext uri="{FF2B5EF4-FFF2-40B4-BE49-F238E27FC236}">
-                <a16:creationId xmlns:a16="http://schemas.microsoft.com/office/drawing/2014/main" id="{488B4EEF-F1DD-4DC5-BBC2-EF600C8F59BF}"/>
+                <a16:creationId xmlns:a16="http://schemas.microsoft.com/office/drawing/2014/main" id="{FFE955E1-B5ED-E4B1-BCAE-5CE8EFDB40EC}"/>
               </a:ext>
             </a:extLst>
           </p:cNvPr>
@@ -2100,7 +2100,7 @@
           <p:cNvPr id="4" name="Slide Number Placeholder 3">
             <a:extLst>
               <a:ext uri="{FF2B5EF4-FFF2-40B4-BE49-F238E27FC236}">
-                <a16:creationId xmlns:a16="http://schemas.microsoft.com/office/drawing/2014/main" id="{C21B3822-167A-7556-E9AF-BA263929C610}"/>
+                <a16:creationId xmlns:a16="http://schemas.microsoft.com/office/drawing/2014/main" id="{06EE08E7-131F-667D-959D-8256837C8458}"/>
               </a:ext>
             </a:extLst>
           </p:cNvPr>
@@ -2116,7 +2116,7 @@
           <a:bodyPr/>
           <a:lstStyle/>
           <a:p>
-            <a:fld id="{DC776238-45DA-4189-B6CA-1B3359F0C924}" type="slidenum">
+            <a:fld id="{E9450F60-D1CA-4FC9-9791-AF0BFD194C99}" type="slidenum">
               <a:rPr lang="en-US" smtClean="0"/>
               <a:t>‹#›</a:t>
             </a:fld>
@@ -2127,7 +2127,7 @@
     </p:spTree>
     <p:extLst>
       <p:ext uri="{BB962C8B-B14F-4D97-AF65-F5344CB8AC3E}">
-        <p14:creationId xmlns:p14="http://schemas.microsoft.com/office/powerpoint/2010/main" val="1025248261"/>
+        <p14:creationId xmlns:p14="http://schemas.microsoft.com/office/powerpoint/2010/main" val="3079546297"/>
       </p:ext>
     </p:extLst>
   </p:cSld>
@@ -2159,7 +2159,7 @@
           <p:cNvPr id="2" name="Title 1">
             <a:extLst>
               <a:ext uri="{FF2B5EF4-FFF2-40B4-BE49-F238E27FC236}">
-                <a16:creationId xmlns:a16="http://schemas.microsoft.com/office/drawing/2014/main" id="{A8D51D7A-F002-0C47-E748-06E3FC3DCFFC}"/>
+                <a16:creationId xmlns:a16="http://schemas.microsoft.com/office/drawing/2014/main" id="{B8F95C31-E45E-AE53-8F76-F84900BDDEA7}"/>
               </a:ext>
             </a:extLst>
           </p:cNvPr>
@@ -2196,7 +2196,7 @@
           <p:cNvPr id="3" name="Content Placeholder 2">
             <a:extLst>
               <a:ext uri="{FF2B5EF4-FFF2-40B4-BE49-F238E27FC236}">
-                <a16:creationId xmlns:a16="http://schemas.microsoft.com/office/drawing/2014/main" id="{E624026E-2174-E3C4-D996-C8E1E60A5E2F}"/>
+                <a16:creationId xmlns:a16="http://schemas.microsoft.com/office/drawing/2014/main" id="{340F2C61-2B0C-234E-4CD7-6DCAA2C9F806}"/>
               </a:ext>
             </a:extLst>
           </p:cNvPr>
@@ -2286,7 +2286,7 @@
           <p:cNvPr id="4" name="Text Placeholder 3">
             <a:extLst>
               <a:ext uri="{FF2B5EF4-FFF2-40B4-BE49-F238E27FC236}">
-                <a16:creationId xmlns:a16="http://schemas.microsoft.com/office/drawing/2014/main" id="{B54B174C-5ECA-4269-6A2E-83E97C1812D8}"/>
+                <a16:creationId xmlns:a16="http://schemas.microsoft.com/office/drawing/2014/main" id="{A9FB0E6F-7CF9-2FF4-5FA5-BCF2A1DAE1D2}"/>
               </a:ext>
             </a:extLst>
           </p:cNvPr>
@@ -2357,7 +2357,7 @@
           <p:cNvPr id="5" name="Date Placeholder 4">
             <a:extLst>
               <a:ext uri="{FF2B5EF4-FFF2-40B4-BE49-F238E27FC236}">
-                <a16:creationId xmlns:a16="http://schemas.microsoft.com/office/drawing/2014/main" id="{A999B6A0-778A-6437-34EF-B011739E5D12}"/>
+                <a16:creationId xmlns:a16="http://schemas.microsoft.com/office/drawing/2014/main" id="{A4B27815-22BC-29B9-8A5A-2AD91CBBD075}"/>
               </a:ext>
             </a:extLst>
           </p:cNvPr>
@@ -2373,9 +2373,9 @@
           <a:bodyPr/>
           <a:lstStyle/>
           <a:p>
-            <a:fld id="{CFB8CEE7-E106-44F4-BA0D-7FD856044FA9}" type="datetimeFigureOut">
+            <a:fld id="{12F0EA5F-F5AC-4C74-89EF-6C6D6C884FA9}" type="datetimeFigureOut">
               <a:rPr lang="en-US" smtClean="0"/>
-              <a:t>5/15/2026</a:t>
+              <a:t>5/16/2026</a:t>
             </a:fld>
             <a:endParaRPr lang="en-US"/>
           </a:p>
@@ -2386,7 +2386,7 @@
           <p:cNvPr id="6" name="Footer Placeholder 5">
             <a:extLst>
               <a:ext uri="{FF2B5EF4-FFF2-40B4-BE49-F238E27FC236}">
-                <a16:creationId xmlns:a16="http://schemas.microsoft.com/office/drawing/2014/main" id="{59F1D153-03AD-4FCA-AF77-213191E03105}"/>
+                <a16:creationId xmlns:a16="http://schemas.microsoft.com/office/drawing/2014/main" id="{36CF5B11-48FC-4BF5-CCD3-C04F26F08185}"/>
               </a:ext>
             </a:extLst>
           </p:cNvPr>
@@ -2411,7 +2411,7 @@
           <p:cNvPr id="7" name="Slide Number Placeholder 6">
             <a:extLst>
               <a:ext uri="{FF2B5EF4-FFF2-40B4-BE49-F238E27FC236}">
-                <a16:creationId xmlns:a16="http://schemas.microsoft.com/office/drawing/2014/main" id="{CF64D94C-25C7-44CB-610C-E72E535C3B16}"/>
+                <a16:creationId xmlns:a16="http://schemas.microsoft.com/office/drawing/2014/main" id="{21E80C04-16A8-5C37-F20C-30F4E9E4DF8E}"/>
               </a:ext>
             </a:extLst>
           </p:cNvPr>
@@ -2427,7 +2427,7 @@
           <a:bodyPr/>
           <a:lstStyle/>
           <a:p>
-            <a:fld id="{DC776238-45DA-4189-B6CA-1B3359F0C924}" type="slidenum">
+            <a:fld id="{E9450F60-D1CA-4FC9-9791-AF0BFD194C99}" type="slidenum">
               <a:rPr lang="en-US" smtClean="0"/>
               <a:t>‹#›</a:t>
             </a:fld>
@@ -2438,7 +2438,7 @@
     </p:spTree>
     <p:extLst>
       <p:ext uri="{BB962C8B-B14F-4D97-AF65-F5344CB8AC3E}">
-        <p14:creationId xmlns:p14="http://schemas.microsoft.com/office/powerpoint/2010/main" val="1553854634"/>
+        <p14:creationId xmlns:p14="http://schemas.microsoft.com/office/powerpoint/2010/main" val="3556716179"/>
       </p:ext>
     </p:extLst>
   </p:cSld>
@@ -2470,7 +2470,7 @@
           <p:cNvPr id="2" name="Title 1">
             <a:extLst>
               <a:ext uri="{FF2B5EF4-FFF2-40B4-BE49-F238E27FC236}">
-                <a16:creationId xmlns:a16="http://schemas.microsoft.com/office/drawing/2014/main" id="{8ED8AF99-2109-F316-27E9-4ECF7292A4CD}"/>
+                <a16:creationId xmlns:a16="http://schemas.microsoft.com/office/drawing/2014/main" id="{4E089D35-B730-211F-A43C-0F93752D6D15}"/>
               </a:ext>
             </a:extLst>
           </p:cNvPr>
@@ -2507,7 +2507,7 @@
           <p:cNvPr id="3" name="Picture Placeholder 2">
             <a:extLst>
               <a:ext uri="{FF2B5EF4-FFF2-40B4-BE49-F238E27FC236}">
-                <a16:creationId xmlns:a16="http://schemas.microsoft.com/office/drawing/2014/main" id="{ECEBA457-F902-2CCD-C8DB-1581829A3F15}"/>
+                <a16:creationId xmlns:a16="http://schemas.microsoft.com/office/drawing/2014/main" id="{2475853C-33D3-4D24-95E5-4A6D0AB4D9EB}"/>
               </a:ext>
             </a:extLst>
           </p:cNvPr>
@@ -2574,7 +2574,7 @@
           <p:cNvPr id="4" name="Text Placeholder 3">
             <a:extLst>
               <a:ext uri="{FF2B5EF4-FFF2-40B4-BE49-F238E27FC236}">
-                <a16:creationId xmlns:a16="http://schemas.microsoft.com/office/drawing/2014/main" id="{028DA2ED-7764-2391-48FA-04B26FCBF980}"/>
+                <a16:creationId xmlns:a16="http://schemas.microsoft.com/office/drawing/2014/main" id="{0D7D5CA6-4AE1-ABDC-5BAB-7E1B316799BD}"/>
               </a:ext>
             </a:extLst>
           </p:cNvPr>
@@ -2645,7 +2645,7 @@
           <p:cNvPr id="5" name="Date Placeholder 4">
             <a:extLst>
               <a:ext uri="{FF2B5EF4-FFF2-40B4-BE49-F238E27FC236}">
-                <a16:creationId xmlns:a16="http://schemas.microsoft.com/office/drawing/2014/main" id="{59ACD5B7-AE80-950A-AA74-0E332F19C85C}"/>
+                <a16:creationId xmlns:a16="http://schemas.microsoft.com/office/drawing/2014/main" id="{9300D0E7-6D57-D34E-5D9C-8BCEDFE5F728}"/>
               </a:ext>
             </a:extLst>
           </p:cNvPr>
@@ -2661,9 +2661,9 @@
           <a:bodyPr/>
           <a:lstStyle/>
           <a:p>
-            <a:fld id="{CFB8CEE7-E106-44F4-BA0D-7FD856044FA9}" type="datetimeFigureOut">
+            <a:fld id="{12F0EA5F-F5AC-4C74-89EF-6C6D6C884FA9}" type="datetimeFigureOut">
               <a:rPr lang="en-US" smtClean="0"/>
-              <a:t>5/15/2026</a:t>
+              <a:t>5/16/2026</a:t>
             </a:fld>
             <a:endParaRPr lang="en-US"/>
           </a:p>
@@ -2674,7 +2674,7 @@
           <p:cNvPr id="6" name="Footer Placeholder 5">
             <a:extLst>
               <a:ext uri="{FF2B5EF4-FFF2-40B4-BE49-F238E27FC236}">
-                <a16:creationId xmlns:a16="http://schemas.microsoft.com/office/drawing/2014/main" id="{0792D1A1-0733-A3E9-C36B-6695053838A6}"/>
+                <a16:creationId xmlns:a16="http://schemas.microsoft.com/office/drawing/2014/main" id="{72FDB33B-62E7-F6EB-1A8E-306B2ECE3BA7}"/>
               </a:ext>
             </a:extLst>
           </p:cNvPr>
@@ -2699,7 +2699,7 @@
           <p:cNvPr id="7" name="Slide Number Placeholder 6">
             <a:extLst>
               <a:ext uri="{FF2B5EF4-FFF2-40B4-BE49-F238E27FC236}">
-                <a16:creationId xmlns:a16="http://schemas.microsoft.com/office/drawing/2014/main" id="{B4999498-5FD7-18B8-C2EB-B562EB1E0DA0}"/>
+                <a16:creationId xmlns:a16="http://schemas.microsoft.com/office/drawing/2014/main" id="{7269DA40-7213-FCE3-8639-E4854E41B9E8}"/>
               </a:ext>
             </a:extLst>
           </p:cNvPr>
@@ -2715,7 +2715,7 @@
           <a:bodyPr/>
           <a:lstStyle/>
           <a:p>
-            <a:fld id="{DC776238-45DA-4189-B6CA-1B3359F0C924}" type="slidenum">
+            <a:fld id="{E9450F60-D1CA-4FC9-9791-AF0BFD194C99}" type="slidenum">
               <a:rPr lang="en-US" smtClean="0"/>
               <a:t>‹#›</a:t>
             </a:fld>
@@ -2726,7 +2726,7 @@
     </p:spTree>
     <p:extLst>
       <p:ext uri="{BB962C8B-B14F-4D97-AF65-F5344CB8AC3E}">
-        <p14:creationId xmlns:p14="http://schemas.microsoft.com/office/powerpoint/2010/main" val="540257469"/>
+        <p14:creationId xmlns:p14="http://schemas.microsoft.com/office/powerpoint/2010/main" val="1208822434"/>
       </p:ext>
     </p:extLst>
   </p:cSld>
@@ -2763,7 +2763,7 @@
           <p:cNvPr id="2" name="Title Placeholder 1">
             <a:extLst>
               <a:ext uri="{FF2B5EF4-FFF2-40B4-BE49-F238E27FC236}">
-                <a16:creationId xmlns:a16="http://schemas.microsoft.com/office/drawing/2014/main" id="{08DD8DDE-88E1-FA84-09B6-66FE977EDCF1}"/>
+                <a16:creationId xmlns:a16="http://schemas.microsoft.com/office/drawing/2014/main" id="{23721C6D-4013-DE1A-99BF-0715BBE41D37}"/>
               </a:ext>
             </a:extLst>
           </p:cNvPr>
@@ -2801,7 +2801,7 @@
           <p:cNvPr id="3" name="Text Placeholder 2">
             <a:extLst>
               <a:ext uri="{FF2B5EF4-FFF2-40B4-BE49-F238E27FC236}">
-                <a16:creationId xmlns:a16="http://schemas.microsoft.com/office/drawing/2014/main" id="{3D8834CE-65ED-4D0F-A73D-23D12A17D9D3}"/>
+                <a16:creationId xmlns:a16="http://schemas.microsoft.com/office/drawing/2014/main" id="{230F0882-897D-2C48-D9C0-ED99174E60DD}"/>
               </a:ext>
             </a:extLst>
           </p:cNvPr>
@@ -2868,7 +2868,7 @@
           <p:cNvPr id="4" name="Date Placeholder 3">
             <a:extLst>
               <a:ext uri="{FF2B5EF4-FFF2-40B4-BE49-F238E27FC236}">
-                <a16:creationId xmlns:a16="http://schemas.microsoft.com/office/drawing/2014/main" id="{78E24FBE-406B-ACD2-852A-7A49EE1BEA67}"/>
+                <a16:creationId xmlns:a16="http://schemas.microsoft.com/office/drawing/2014/main" id="{30C47E55-03C7-1A5A-EB4B-1D127F948E84}"/>
               </a:ext>
             </a:extLst>
           </p:cNvPr>
@@ -2902,9 +2902,9 @@
             </a:lvl1pPr>
           </a:lstStyle>
           <a:p>
-            <a:fld id="{CFB8CEE7-E106-44F4-BA0D-7FD856044FA9}" type="datetimeFigureOut">
+            <a:fld id="{12F0EA5F-F5AC-4C74-89EF-6C6D6C884FA9}" type="datetimeFigureOut">
               <a:rPr lang="en-US" smtClean="0"/>
-              <a:t>5/15/2026</a:t>
+              <a:t>5/16/2026</a:t>
             </a:fld>
             <a:endParaRPr lang="en-US"/>
           </a:p>
@@ -2915,7 +2915,7 @@
           <p:cNvPr id="5" name="Footer Placeholder 4">
             <a:extLst>
               <a:ext uri="{FF2B5EF4-FFF2-40B4-BE49-F238E27FC236}">
-                <a16:creationId xmlns:a16="http://schemas.microsoft.com/office/drawing/2014/main" id="{3F812062-08DD-DEDF-D047-72C5C7852C6F}"/>
+                <a16:creationId xmlns:a16="http://schemas.microsoft.com/office/drawing/2014/main" id="{55E7B84B-E1D6-566D-F536-947F7EF699E2}"/>
               </a:ext>
             </a:extLst>
           </p:cNvPr>
@@ -2958,7 +2958,7 @@
           <p:cNvPr id="6" name="Slide Number Placeholder 5">
             <a:extLst>
               <a:ext uri="{FF2B5EF4-FFF2-40B4-BE49-F238E27FC236}">
-                <a16:creationId xmlns:a16="http://schemas.microsoft.com/office/drawing/2014/main" id="{ECF5D100-B987-8A9D-AF0F-AE93BC093F31}"/>
+                <a16:creationId xmlns:a16="http://schemas.microsoft.com/office/drawing/2014/main" id="{F97C0523-99CA-ECB4-2727-9B295F6C3599}"/>
               </a:ext>
             </a:extLst>
           </p:cNvPr>
@@ -2992,7 +2992,7 @@
             </a:lvl1pPr>
           </a:lstStyle>
           <a:p>
-            <a:fld id="{DC776238-45DA-4189-B6CA-1B3359F0C924}" type="slidenum">
+            <a:fld id="{E9450F60-D1CA-4FC9-9791-AF0BFD194C99}" type="slidenum">
               <a:rPr lang="en-US" smtClean="0"/>
               <a:t>‹#›</a:t>
             </a:fld>
@@ -3003,7 +3003,7 @@
     </p:spTree>
     <p:extLst>
       <p:ext uri="{BB962C8B-B14F-4D97-AF65-F5344CB8AC3E}">
-        <p14:creationId xmlns:p14="http://schemas.microsoft.com/office/powerpoint/2010/main" val="2968334600"/>
+        <p14:creationId xmlns:p14="http://schemas.microsoft.com/office/powerpoint/2010/main" val="2579570735"/>
       </p:ext>
     </p:extLst>
   </p:cSld>
@@ -3323,10 +3323,10 @@
       </p:grpSpPr>
       <p:sp>
         <p:nvSpPr>
-          <p:cNvPr id="2" name="Rectangle 1">
-            <a:extLst>
-              <a:ext uri="{FF2B5EF4-FFF2-40B4-BE49-F238E27FC236}">
-                <a16:creationId xmlns:a16="http://schemas.microsoft.com/office/drawing/2014/main" id="{BABC134C-89E6-F158-5508-26C3E688D6CC}"/>
+          <p:cNvPr id="2" name="Heart 1">
+            <a:extLst>
+              <a:ext uri="{FF2B5EF4-FFF2-40B4-BE49-F238E27FC236}">
+                <a16:creationId xmlns:a16="http://schemas.microsoft.com/office/drawing/2014/main" id="{F962C1E4-1AA5-1B6B-D29C-014734C420C3}"/>
               </a:ext>
             </a:extLst>
           </p:cNvPr>
@@ -3335,10 +3335,10 @@
         </p:nvSpPr>
         <p:spPr>
           <a:xfrm>
-            <a:off x="2743200" y="2057400"/>
-            <a:ext cx="3657600" cy="2286000"/>
+            <a:off x="3810000" y="2286000"/>
+            <a:ext cx="2286000" cy="2032000"/>
           </a:xfrm>
-          <a:prstGeom prst="rect">
+          <a:prstGeom prst="heart">
             <a:avLst/>
           </a:prstGeom>
           <a:blipFill>
@@ -3395,7 +3395,7 @@
     </p:spTree>
     <p:extLst>
       <p:ext uri="{BB962C8B-B14F-4D97-AF65-F5344CB8AC3E}">
-        <p14:creationId xmlns:p14="http://schemas.microsoft.com/office/powerpoint/2010/main" val="1416106629"/>
+        <p14:creationId xmlns:p14="http://schemas.microsoft.com/office/powerpoint/2010/main" val="1603535003"/>
       </p:ext>
     </p:extLst>
   </p:cSld>

</xml_diff>